<commit_message>
Replace Berlin with Sydney as Wave 1 launch city
Germany removed due to UWG/GDPR cold-outreach email restrictions blocking
the n8n scraping strategy. Sydney (AU) added — already at 52/60 sellers.

Updated: AGENT_BRIEFING.md, MarketSquare_LaunchPlan.pptx (slides 1, 2, 6)

Co-Authored-By: Claude Sonnet 4.6 <noreply@anthropic.com>
</commit_message>
<xml_diff>
--- a/MarketSquare_LaunchPlan.pptx
+++ b/MarketSquare_LaunchPlan.pptx
@@ -1734,7 +1734,7 @@
                 <a:ea typeface="Calibri" pitchFamily="34" charset="-122"/>
                 <a:cs typeface="Calibri" pitchFamily="34" charset="-120"/>
               </a:rPr>
-              <a:t>Berlin</a:t>
+              <a:t>Sydney</a:t>
             </a:r>
             <a:endParaRPr lang="en-US" sz="1100" dirty="0"/>
           </a:p>
@@ -1876,7 +1876,7 @@
                 <a:ea typeface="Calibri" pitchFamily="34" charset="-122"/>
                 <a:cs typeface="Calibri" pitchFamily="34" charset="-120"/>
               </a:rPr>
-              <a:t>Wave 1  ·  Pretoria  ·  New York  ·  London  ·  Berlin</a:t>
+              <a:t>Wave 1  ·  Pretoria  ·  New York  ·  London  ·  Sydney</a:t>
             </a:r>
             <a:endParaRPr lang="en-US" sz="1600" dirty="0"/>
           </a:p>
@@ -3199,7 +3199,7 @@
                 <a:ea typeface="Calibri" pitchFamily="34" charset="-122"/>
                 <a:cs typeface="Calibri" pitchFamily="34" charset="-120"/>
               </a:rPr>
-              <a:t>-&gt;  Berlin pipeline not started</a:t>
+              <a:t>-&gt;  Sydney pipeline: 52/60 sellers confirmed</a:t>
             </a:r>
             <a:endParaRPr lang="en-US" sz="1300" dirty="0"/>
           </a:p>
@@ -8555,7 +8555,7 @@
                 <a:ea typeface="Calibri" pitchFamily="34" charset="-122"/>
                 <a:cs typeface="Calibri" pitchFamily="34" charset="-120"/>
               </a:rPr>
-              <a:t>International entity (NY/LON/BER)</a:t>
+              <a:t>International entity (NY/LON/SYD)</a:t>
             </a:r>
             <a:endParaRPr lang="en-US" sz="1250" dirty="0"/>
           </a:p>
@@ -8845,7 +8845,7 @@
                 <a:ea typeface="Calibri" pitchFamily="34" charset="-122"/>
                 <a:cs typeface="Calibri" pitchFamily="34" charset="-120"/>
               </a:rPr>
-              <a:t>60 sellers each (NY · LON · BER)</a:t>
+              <a:t>60 sellers each (NY · LON · SYD)</a:t>
             </a:r>
             <a:endParaRPr lang="en-US" sz="1250" dirty="0"/>
           </a:p>

</xml_diff>